<commit_message>
Document the response and evidence capabilities; refresh briefing collateral
How-to: protection response playbooks table, new sensors, staging checks
10-13, test map and controls summary. README and engineering guide cover
the protection service invariants. Deck gains a ransomware and log-tamper
slide and an updated containment slide; email and test count (486) updated.

Co-Authored-By: Claude Fable 5.1 <noreply@anthropic.com>
</commit_message>
<xml_diff>
--- a/VulnSuite_Executive_Deck_FINAL.pptx
+++ b/VulnSuite_Executive_Deck_FINAL.pptx
@@ -29,6 +29,7 @@
     <p:sldId id="277" r:id="rId29"/>
     <p:sldId id="278" r:id="rId30"/>
     <p:sldId id="279" r:id="rId31"/>
+    <p:sldId id="280" r:id="rId32"/>
   </p:sldIdLst>
   <p:sldSz cx="12191695" cy="6858000" type="screen4x3"/>
   <p:notesSz cx="6858000" cy="9144000"/>
@@ -1190,12 +1191,12 @@
           <a:lstStyle/>
           <a:p>
             <a:r>
-              <a:t>Containment can interrupt business services, so response decisions need clear evidence and accountability. VulnSuite places supported file quarantine and host isolation behind separate approval and local policy checks, with recorded outcomes and reviewed recovery paths.</a:t>
-            </a:r>
-          </a:p>
-          <a:p>
-            <a:r>
-              <a:t>Scope: Containment is disabled by default. Windows expiry uses local recovery tasks; Linux uses kernel timeouts.</a:t>
+              <a:t>Containment can interrupt business services, so response decisions need clear evidence and accountability. VulnSuite places file quarantine, process termination, host isolation, identity and WAF response behind separate approval and local policy checks, with recorded outcomes and reviewed recovery paths.</a:t>
+            </a:r>
+          </a:p>
+          <a:p>
+            <a:r>
+              <a:t>Scope: Containment is disabled by default. Every action needs a second administrator; pre-approved isolation exists only for ransomware with dual opt-in.</a:t>
             </a:r>
           </a:p>
           <a:p>
@@ -1285,12 +1286,12 @@
           <a:lstStyle/>
           <a:p>
             <a:r>
-              <a:t>The assessment service evaluates exposure; the protection service handles telemetry, investigations and response. Their separate responsibilities help teams plan access, storage, maintenance and integration around the requirements of each service.</a:t>
-            </a:r>
-          </a:p>
-          <a:p>
-            <a:r>
-              <a:t>Scope: SQLite protection persistence is not a horizontally scalable or highly available PostgreSQL backend.</a:t>
+              <a:t>Attackers encrypt data and erase their tracks. Decoy files, change-rate and entropy signals give the SOC minutes of warning on a share, while tamper signals, sequence numbers and a hash chain show when logs or stored evidence were altered, by which process and when.</a:t>
+            </a:r>
+          </a:p>
+          <a:p>
+            <a:r>
+              <a:t>Scope: Encryption is detected at the next poll, not prevented; backups decide the outcome. The chain proves alteration, the off-host copy is the protection.</a:t>
             </a:r>
           </a:p>
           <a:p>
@@ -1380,12 +1381,12 @@
           <a:lstStyle/>
           <a:p>
             <a:r>
-              <a:t>Host monitoring depends on knowing which agents are enrolled, authorised and reporting correctly. Central lifecycle controls help maintain that inventory, replace credentials, withdraw access and identify policy or version differences that require administrator attention.</a:t>
-            </a:r>
-          </a:p>
-          <a:p>
-            <a:r>
-              <a:t>Scope: Agent software installation and upgrades use an administrator-controlled rollout.</a:t>
+              <a:t>The assessment service evaluates exposure; the protection service handles telemetry, investigations and response. Their separate responsibilities help teams plan access, storage, maintenance and integration around the requirements of each service.</a:t>
+            </a:r>
+          </a:p>
+          <a:p>
+            <a:r>
+              <a:t>Scope: SQLite protection persistence is not a horizontally scalable or highly available PostgreSQL backend.</a:t>
             </a:r>
           </a:p>
           <a:p>
@@ -1475,12 +1476,12 @@
           <a:lstStyle/>
           <a:p>
             <a:r>
-              <a:t>Investigations often involve several people and external operational systems. Incident records preserve ownership and decisions, while signed notifications carry relevant information to organisation-operated integrations, helping teams coordinate work and recover delivery after temporary service failures.</a:t>
-            </a:r>
-          </a:p>
-          <a:p>
-            <a:r>
-              <a:t>Scope: Webhooks support organisation-operated adapters; native Jira, ServiceNow or Splunk connectors are not implied.</a:t>
+              <a:t>Host monitoring depends on knowing which agents are enrolled, authorised and reporting correctly. Central lifecycle controls help maintain that inventory, replace credentials, withdraw access and identify policy or version differences that require administrator attention.</a:t>
+            </a:r>
+          </a:p>
+          <a:p>
+            <a:r>
+              <a:t>Scope: Agent software installation and upgrades use an administrator-controlled rollout.</a:t>
             </a:r>
           </a:p>
           <a:p>
@@ -1665,12 +1666,12 @@
           <a:lstStyle/>
           <a:p>
             <a:r>
-              <a:t>Network interruptions and growing evidence volumes can affect security operations. Persistent queues and acknowledgement checks support recovery after outages, while backup and retention controls help teams manage stored evidence according to investigation needs and operational requirements.</a:t>
-            </a:r>
-          </a:p>
-          <a:p>
-            <a:r>
-              <a:t>Scope: Schedule maintenance explicitly and measure capacity, recovery objectives and backup security in the target environment.</a:t>
+              <a:t>Investigations often involve several people and external operational systems. Incident records preserve ownership and decisions, while signed notifications carry relevant information to organisation-operated integrations, helping teams coordinate work and recover delivery after temporary service failures.</a:t>
+            </a:r>
+          </a:p>
+          <a:p>
+            <a:r>
+              <a:t>Scope: Webhooks support organisation-operated adapters; native Jira, ServiceNow or Splunk connectors are not implied.</a:t>
             </a:r>
           </a:p>
           <a:p>
@@ -1760,12 +1761,12 @@
           <a:lstStyle/>
           <a:p>
             <a:r>
-              <a:t>A security tool that downloads twenty scanners is a supply-chain target. Every binary in the image is pinned to a known checksum and verified at build time, the containers run unprivileged, and the whole stack can operate without internet access using locally mirrored vulnerability data.</a:t>
-            </a:r>
-          </a:p>
-          <a:p>
-            <a:r>
-              <a:t>Scope: Tests fail the build if any download lacks a pin or the runtime user is removed.</a:t>
+              <a:t>Network interruptions and growing evidence volumes can affect security operations. Persistent queues and acknowledgement checks support recovery after outages, while backup and retention controls help teams manage stored evidence according to investigation needs and operational requirements.</a:t>
+            </a:r>
+          </a:p>
+          <a:p>
+            <a:r>
+              <a:t>Scope: Schedule maintenance explicitly and measure capacity, recovery objectives and backup security in the target environment.</a:t>
             </a:r>
           </a:p>
           <a:p>
@@ -1855,12 +1856,12 @@
           <a:lstStyle/>
           <a:p>
             <a:r>
-              <a:t>The validation results demonstrate exercised code paths and selected native file behaviours. They provide evidence for technical review, while full containment effectiveness, host compatibility and operational performance require testing in the intended environment.</a:t>
-            </a:r>
-          </a:p>
-          <a:p>
-            <a:r>
-              <a:t>Scope: Automated tests and narrow native file checks do not establish live containment efficacy or production readiness.</a:t>
+              <a:t>A security tool that downloads twenty scanners is a supply-chain target. Every binary in the image is pinned to a known checksum and verified at build time, the containers run unprivileged, and the whole stack can operate without internet access using locally mirrored vulnerability data.</a:t>
+            </a:r>
+          </a:p>
+          <a:p>
+            <a:r>
+              <a:t>Scope: Tests fail the build if any download lacks a pin or the runtime user is removed.</a:t>
             </a:r>
           </a:p>
           <a:p>
@@ -1950,12 +1951,12 @@
           <a:lstStyle/>
           <a:p>
             <a:r>
-              <a:t>Deployment conditions determine whether security controls work as intended. Staging should verify identity, database roles, telemetry, permissions, enforcement and recovery together, including how containment behaves during service interruptions and host restarts.</a:t>
-            </a:r>
-          </a:p>
-          <a:p>
-            <a:r>
-              <a:t>Scope: Validate native Windows ACLs, firewall enforcement, scheduled-task expiry and reboot recovery before enabling containment.</a:t>
+              <a:t>The validation results demonstrate exercised code paths and selected native file behaviours. They provide evidence for technical review, while full containment effectiveness, host compatibility and operational performance require testing in the intended environment.</a:t>
+            </a:r>
+          </a:p>
+          <a:p>
+            <a:r>
+              <a:t>Scope: Automated tests and narrow native file checks do not establish live containment efficacy or production readiness.</a:t>
             </a:r>
           </a:p>
           <a:p>
@@ -2001,6 +2002,101 @@
 </file>
 
 <file path=ppt/notesSlides/notesSlide24.xml><?xml version="1.0" encoding="utf-8"?>
+<p:notes xmlns:a="http://schemas.openxmlformats.org/drawingml/2006/main" xmlns:p="http://schemas.openxmlformats.org/presentationml/2006/main" xmlns:r="http://schemas.openxmlformats.org/officeDocument/2006/relationships">
+  <p:cSld>
+    <p:spTree>
+      <p:nvGrpSpPr>
+        <p:cNvPr id="1" name=""/>
+        <p:cNvGrpSpPr/>
+        <p:nvPr/>
+      </p:nvGrpSpPr>
+      <p:grpSpPr>
+        <a:xfrm>
+          <a:off x="0" y="0"/>
+          <a:ext cx="0" cy="0"/>
+          <a:chOff x="0" y="0"/>
+          <a:chExt cx="0" cy="0"/>
+        </a:xfrm>
+      </p:grpSpPr>
+      <p:sp>
+        <p:nvSpPr>
+          <p:cNvPr id="2" name="Slide Image Placeholder 1"/>
+          <p:cNvSpPr>
+            <a:spLocks noGrp="1"/>
+          </p:cNvSpPr>
+          <p:nvPr>
+            <p:ph type="sldImg" idx="2"/>
+          </p:nvPr>
+        </p:nvSpPr>
+        <p:spPr/>
+      </p:sp>
+      <p:sp>
+        <p:nvSpPr>
+          <p:cNvPr id="3" name="Notes Placeholder 2"/>
+          <p:cNvSpPr>
+            <a:spLocks noGrp="1"/>
+          </p:cNvSpPr>
+          <p:nvPr>
+            <p:ph type="body" idx="3" sz="quarter"/>
+          </p:nvPr>
+        </p:nvSpPr>
+        <p:spPr/>
+        <p:txBody>
+          <a:bodyPr/>
+          <a:lstStyle/>
+          <a:p>
+            <a:r>
+              <a:t>Deployment conditions determine whether security controls work as intended. Staging should verify identity, database roles, telemetry, permissions, enforcement and recovery together, including how containment behaves during service interruptions and host restarts.</a:t>
+            </a:r>
+          </a:p>
+          <a:p>
+            <a:r>
+              <a:t>Scope: Validate native Windows ACLs, firewall enforcement, scheduled-task expiry and reboot recovery before enabling containment.</a:t>
+            </a:r>
+          </a:p>
+          <a:p>
+            <a:r>
+              <a:t>How to use: docs/HOW_TO_USE.md</a:t>
+            </a:r>
+          </a:p>
+          <a:p>
+            <a:r>
+              <a:t>Engineering reference: vulnsuite/CLAUDE.md</a:t>
+            </a:r>
+          </a:p>
+          <a:p>
+            <a:r>
+              <a:t>Protection operations: vulnsuite/protection/OPERATIONS.md and deploy/protection/OPERATIONS.md</a:t>
+            </a:r>
+          </a:p>
+          <a:p>
+            <a:r>
+              <a:t>Automated validation does not establish live enforcement or full EDR coverage.</a:t>
+            </a:r>
+          </a:p>
+        </p:txBody>
+      </p:sp>
+      <p:sp>
+        <p:nvSpPr>
+          <p:cNvPr id="4" name="Slide Number Placeholder 3"/>
+          <p:cNvSpPr>
+            <a:spLocks noGrp="1"/>
+          </p:cNvSpPr>
+          <p:nvPr>
+            <p:ph type="sldNum" idx="5" sz="quarter"/>
+          </p:nvPr>
+        </p:nvSpPr>
+        <p:spPr/>
+      </p:sp>
+    </p:spTree>
+  </p:cSld>
+  <p:clrMapOvr>
+    <a:masterClrMapping/>
+  </p:clrMapOvr>
+</p:notes>
+</file>
+
+<file path=ppt/notesSlides/notesSlide25.xml><?xml version="1.0" encoding="utf-8"?>
 <p:notes xmlns:a="http://schemas.openxmlformats.org/drawingml/2006/main" xmlns:p="http://schemas.openxmlformats.org/presentationml/2006/main" xmlns:r="http://schemas.openxmlformats.org/officeDocument/2006/relationships">
   <p:cSld>
     <p:spTree>
@@ -6472,7 +6568,7 @@
               </a:defRPr>
             </a:pPr>
             <a:r>
-              <a:t>01 / 24</a:t>
+              <a:t>01 / 25</a:t>
             </a:r>
           </a:p>
         </p:txBody>
@@ -7226,7 +7322,7 @@
               </a:defRPr>
             </a:pPr>
             <a:r>
-              <a:t>10 / 24</a:t>
+              <a:t>10 / 25</a:t>
             </a:r>
           </a:p>
         </p:txBody>
@@ -7980,7 +8076,7 @@
               </a:defRPr>
             </a:pPr>
             <a:r>
-              <a:t>11 / 24</a:t>
+              <a:t>11 / 25</a:t>
             </a:r>
           </a:p>
         </p:txBody>
@@ -8734,7 +8830,7 @@
               </a:defRPr>
             </a:pPr>
             <a:r>
-              <a:t>12 / 24</a:t>
+              <a:t>12 / 25</a:t>
             </a:r>
           </a:p>
         </p:txBody>
@@ -9488,7 +9584,7 @@
               </a:defRPr>
             </a:pPr>
             <a:r>
-              <a:t>13 / 24</a:t>
+              <a:t>13 / 25</a:t>
             </a:r>
           </a:p>
         </p:txBody>
@@ -10242,7 +10338,7 @@
               </a:defRPr>
             </a:pPr>
             <a:r>
-              <a:t>14 / 24</a:t>
+              <a:t>14 / 25</a:t>
             </a:r>
           </a:p>
         </p:txBody>
@@ -10996,7 +11092,7 @@
               </a:defRPr>
             </a:pPr>
             <a:r>
-              <a:t>15 / 24</a:t>
+              <a:t>15 / 25</a:t>
             </a:r>
           </a:p>
         </p:txBody>
@@ -11135,7 +11231,7 @@
               </a:defRPr>
             </a:pPr>
             <a:r>
-              <a:t>Reviewed local containment</a:t>
+              <a:t>Reviewed containment and response</a:t>
             </a:r>
           </a:p>
         </p:txBody>
@@ -11177,7 +11273,7 @@
               </a:defRPr>
             </a:pPr>
             <a:r>
-              <a:t>Containment can interrupt business services, so response decisions need clear evidence and accountability. VulnSuite places supported file quarantine and host isolation behind separate approval and local policy checks, with recorded outcomes and reviewed recovery paths.</a:t>
+              <a:t>Containment can interrupt business services, so response decisions need clear evidence and accountability. VulnSuite places file quarantine, process termination, host isolation, identity and WAF response behind separate approval and local policy checks, with recorded outcomes and reviewed recovery paths.</a:t>
             </a:r>
           </a:p>
         </p:txBody>
@@ -11302,7 +11398,7 @@
               </a:defRPr>
             </a:pPr>
             <a:r>
-              <a:t>Quarantine and restoration</a:t>
+              <a:t>On the host</a:t>
             </a:r>
           </a:p>
         </p:txBody>
@@ -11345,7 +11441,7 @@
               </a:defRPr>
             </a:pPr>
             <a:r>
-              <a:t>Use approved malware path and SHA256 evidence</a:t>
+              <a:t>Quarantine with approved path and SHA256 evidence</a:t>
             </a:r>
           </a:p>
           <a:p>
@@ -11365,7 +11461,7 @@
               </a:defRPr>
             </a:pPr>
             <a:r>
-              <a:t>Linux: private same-filesystem quarantine vault</a:t>
+              <a:t>Process termination after an identity re-check</a:t>
             </a:r>
           </a:p>
           <a:p>
@@ -11385,7 +11481,7 @@
               </a:defRPr>
             </a:pPr>
             <a:r>
-              <a:t>Windows: file-handle checks and protected ACLs</a:t>
+              <a:t>Isolation with kernel or scheduled-task expiry</a:t>
             </a:r>
           </a:p>
           <a:p>
@@ -11405,7 +11501,7 @@
               </a:defRPr>
             </a:pPr>
             <a:r>
-              <a:t>Restore without overwriting existing files</a:t>
+              <a:t>Restore and release as separately approved rollbacks</a:t>
             </a:r>
           </a:p>
         </p:txBody>
@@ -11530,7 +11626,7 @@
               </a:defRPr>
             </a:pPr>
             <a:r>
-              <a:t>Isolation and release</a:t>
+              <a:t>In the identity provider and WAF</a:t>
             </a:r>
           </a:p>
         </p:txBody>
@@ -11573,7 +11669,7 @@
               </a:defRPr>
             </a:pPr>
             <a:r>
-              <a:t>Require separate approval and local policy</a:t>
+              <a:t>Entra ID session revocation, one shot</a:t>
             </a:r>
           </a:p>
           <a:p>
@@ -11593,7 +11689,7 @@
               </a:defRPr>
             </a:pPr>
             <a:r>
-              <a:t>Linux: kernel-expiring nftables isolation</a:t>
+              <a:t>Entra ID account disable for a fixed window</a:t>
             </a:r>
           </a:p>
           <a:p>
@@ -11613,7 +11709,7 @@
               </a:defRPr>
             </a:pPr>
             <a:r>
-              <a:t>Windows: firewall rules with local recovery tasks</a:t>
+              <a:t>Cloudflare block with provider-evaluated expiry</a:t>
             </a:r>
           </a:p>
           <a:p>
@@ -11633,7 +11729,7 @@
               </a:defRPr>
             </a:pPr>
             <a:r>
-              <a:t>Keep configured management exceptions</a:t>
+              <a:t>Protected users, domains and executables enforced twice</a:t>
             </a:r>
           </a:p>
         </p:txBody>
@@ -11672,7 +11768,7 @@
               </a:defRPr>
             </a:pPr>
             <a:r>
-              <a:t>Containment is disabled by default. Windows expiry uses local recovery tasks; Linux uses kernel timeouts.</a:t>
+              <a:t>Containment is disabled by default. Every action needs a second administrator; pre-approved isolation exists only for ransomware with dual opt-in.</a:t>
             </a:r>
           </a:p>
         </p:txBody>
@@ -11750,7 +11846,7 @@
               </a:defRPr>
             </a:pPr>
             <a:r>
-              <a:t>16 / 24</a:t>
+              <a:t>16 / 25</a:t>
             </a:r>
           </a:p>
         </p:txBody>
@@ -11850,7 +11946,7 @@
               </a:defRPr>
             </a:pPr>
             <a:r>
-              <a:t>PLATFORM ARCHITECTURE</a:t>
+              <a:t>EARLY WARNING + EVIDENCE INTEGRITY</a:t>
             </a:r>
           </a:p>
         </p:txBody>
@@ -11889,7 +11985,7 @@
               </a:defRPr>
             </a:pPr>
             <a:r>
-              <a:t>How the components fit</a:t>
+              <a:t>Ransomware and log-tamper signals</a:t>
             </a:r>
           </a:p>
         </p:txBody>
@@ -11931,7 +12027,7 @@
               </a:defRPr>
             </a:pPr>
             <a:r>
-              <a:t>The assessment service evaluates exposure; the protection service handles telemetry, investigations and response. Their separate responsibilities help teams plan access, storage, maintenance and integration around the requirements of each service.</a:t>
+              <a:t>Attackers encrypt data and erase their tracks. Decoy files, change-rate and entropy signals give the SOC minutes of warning on a share, while tamper signals, sequence numbers and a hash chain show when logs or stored evidence were altered, by which process and when.</a:t>
             </a:r>
           </a:p>
         </p:txBody>
@@ -12056,7 +12152,7 @@
               </a:defRPr>
             </a:pPr>
             <a:r>
-              <a:t>Assessment service</a:t>
+              <a:t>Ransomware early warning</a:t>
             </a:r>
           </a:p>
         </p:txBody>
@@ -12099,7 +12195,7 @@
               </a:defRPr>
             </a:pPr>
             <a:r>
-              <a:t>FastAPI service, Celery workers and nightly scheduler</a:t>
+              <a:t>Canary documents nothing legitimate touches</a:t>
             </a:r>
           </a:p>
           <a:p>
@@ -12119,7 +12215,7 @@
               </a:defRPr>
             </a:pPr>
             <a:r>
-              <a:t>PostgreSQL with tenant policies, Redis broker and cache</a:t>
+              <a:t>Mass rename, rewrite and deletion thresholds</a:t>
             </a:r>
           </a:p>
           <a:p>
@@ -12139,7 +12235,7 @@
               </a:defRPr>
             </a:pPr>
             <a:r>
-              <a:t>Canonical findings, dedup and deterministic risk scoring</a:t>
+              <a:t>High-entropy rewrites sampled from changed files</a:t>
             </a:r>
           </a:p>
           <a:p>
@@ -12159,7 +12255,7 @@
               </a:defRPr>
             </a:pPr>
             <a:r>
-              <a:t>Read-only findings feed into the operations console</a:t>
+              <a:t>Critical alert; optional pre-approved isolation</a:t>
             </a:r>
           </a:p>
         </p:txBody>
@@ -12284,7 +12380,7 @@
               </a:defRPr>
             </a:pPr>
             <a:r>
-              <a:t>Protection service</a:t>
+              <a:t>Log and record integrity</a:t>
             </a:r>
           </a:p>
         </p:txBody>
@@ -12327,7 +12423,7 @@
               </a:defRPr>
             </a:pPr>
             <a:r>
-              <a:t>Authenticated Linux and Windows agents</a:t>
+              <a:t>Truncated, deleted or replaced log files reported</a:t>
             </a:r>
           </a:p>
           <a:p>
@@ -12347,7 +12443,7 @@
               </a:defRPr>
             </a:pPr>
             <a:r>
-              <a:t>One organisation per SQLite operational store</a:t>
+              <a:t>auditd watch records with executable, PID and uid</a:t>
             </a:r>
           </a:p>
           <a:p>
@@ -12367,7 +12463,7 @@
               </a:defRPr>
             </a:pPr>
             <a:r>
-              <a:t>Detection, incidents, policies and response history</a:t>
+              <a:t>Windows log cleared and audit policy changes</a:t>
             </a:r>
           </a:p>
           <a:p>
@@ -12387,7 +12483,7 @@
               </a:defRPr>
             </a:pPr>
             <a:r>
-              <a:t>Independent delivery and cloud-response worker</a:t>
+              <a:t>Sequence numbers and a hash chain with SIEM checkpoints</a:t>
             </a:r>
           </a:p>
         </p:txBody>
@@ -12426,7 +12522,7 @@
               </a:defRPr>
             </a:pPr>
             <a:r>
-              <a:t>SQLite protection persistence is not a horizontally scalable or highly available PostgreSQL backend.</a:t>
+              <a:t>Encryption is detected at the next poll, not prevented; backups decide the outcome. The chain proves alteration, the off-host copy is the protection.</a:t>
             </a:r>
           </a:p>
         </p:txBody>
@@ -12504,7 +12600,7 @@
               </a:defRPr>
             </a:pPr>
             <a:r>
-              <a:t>17 / 24</a:t>
+              <a:t>17 / 25</a:t>
             </a:r>
           </a:p>
         </p:txBody>
@@ -12604,7 +12700,7 @@
               </a:defRPr>
             </a:pPr>
             <a:r>
-              <a:t>ENROLLMENT + POLICY + HEALTH</a:t>
+              <a:t>PLATFORM ARCHITECTURE</a:t>
             </a:r>
           </a:p>
         </p:txBody>
@@ -12643,7 +12739,7 @@
               </a:defRPr>
             </a:pPr>
             <a:r>
-              <a:t>Central agent lifecycle</a:t>
+              <a:t>How the components fit</a:t>
             </a:r>
           </a:p>
         </p:txBody>
@@ -12685,7 +12781,7 @@
               </a:defRPr>
             </a:pPr>
             <a:r>
-              <a:t>Host monitoring depends on knowing which agents are enrolled, authorised and reporting correctly. Central lifecycle controls help maintain that inventory, replace credentials, withdraw access and identify policy or version differences that require administrator attention.</a:t>
+              <a:t>The assessment service evaluates exposure; the protection service handles telemetry, investigations and response. Their separate responsibilities help teams plan access, storage, maintenance and integration around the requirements of each service.</a:t>
             </a:r>
           </a:p>
         </p:txBody>
@@ -12810,7 +12906,7 @@
               </a:defRPr>
             </a:pPr>
             <a:r>
-              <a:t>Credential management</a:t>
+              <a:t>Assessment service</a:t>
             </a:r>
           </a:p>
         </p:txBody>
@@ -12853,7 +12949,7 @@
               </a:defRPr>
             </a:pPr>
             <a:r>
-              <a:t>Issue expiring, one-time enrollment credentials</a:t>
+              <a:t>FastAPI service, Celery workers and nightly scheduler</a:t>
             </a:r>
           </a:p>
           <a:p>
@@ -12873,7 +12969,7 @@
               </a:defRPr>
             </a:pPr>
             <a:r>
-              <a:t>Store hashes of enrolled host credentials</a:t>
+              <a:t>PostgreSQL with tenant policies, Redis broker and cache</a:t>
             </a:r>
           </a:p>
           <a:p>
@@ -12893,7 +12989,7 @@
               </a:defRPr>
             </a:pPr>
             <a:r>
-              <a:t>Rotate keys and revoke agent access centrally</a:t>
+              <a:t>Canonical findings, dedup and deterministic risk scoring</a:t>
             </a:r>
           </a:p>
           <a:p>
@@ -12913,7 +13009,7 @@
               </a:defRPr>
             </a:pPr>
             <a:r>
-              <a:t>Cancel unexecuted responses after revocation</a:t>
+              <a:t>Read-only findings feed into the operations console</a:t>
             </a:r>
           </a:p>
         </p:txBody>
@@ -13038,7 +13134,7 @@
               </a:defRPr>
             </a:pPr>
             <a:r>
-              <a:t>Inventory and policy</a:t>
+              <a:t>Protection service</a:t>
             </a:r>
           </a:p>
         </p:txBody>
@@ -13081,7 +13177,7 @@
               </a:defRPr>
             </a:pPr>
             <a:r>
-              <a:t>Track platform, agent version and queue health</a:t>
+              <a:t>Authenticated Linux and Windows agents</a:t>
             </a:r>
           </a:p>
           <a:p>
@@ -13101,7 +13197,7 @@
               </a:defRPr>
             </a:pPr>
             <a:r>
-              <a:t>Record administrator policy-version history</a:t>
+              <a:t>One organisation per SQLite operational store</a:t>
             </a:r>
           </a:p>
           <a:p>
@@ -13121,7 +13217,7 @@
               </a:defRPr>
             </a:pPr>
             <a:r>
-              <a:t>Flag drift from the desired software version</a:t>
+              <a:t>Detection, incidents, policies and response history</a:t>
             </a:r>
           </a:p>
           <a:p>
@@ -13141,7 +13237,7 @@
               </a:defRPr>
             </a:pPr>
             <a:r>
-              <a:t>Keep privileged response enablement local to hosts</a:t>
+              <a:t>Independent delivery and cloud-response worker</a:t>
             </a:r>
           </a:p>
         </p:txBody>
@@ -13180,7 +13276,7 @@
               </a:defRPr>
             </a:pPr>
             <a:r>
-              <a:t>Agent software installation and upgrades use an administrator-controlled rollout.</a:t>
+              <a:t>SQLite protection persistence is not a horizontally scalable or highly available PostgreSQL backend.</a:t>
             </a:r>
           </a:p>
         </p:txBody>
@@ -13258,7 +13354,7 @@
               </a:defRPr>
             </a:pPr>
             <a:r>
-              <a:t>18 / 24</a:t>
+              <a:t>18 / 25</a:t>
             </a:r>
           </a:p>
         </p:txBody>
@@ -13358,7 +13454,7 @@
               </a:defRPr>
             </a:pPr>
             <a:r>
-              <a:t>OWNERSHIP + EVIDENCE + DELIVERY</a:t>
+              <a:t>ENROLLMENT + POLICY + HEALTH</a:t>
             </a:r>
           </a:p>
         </p:txBody>
@@ -13397,7 +13493,7 @@
               </a:defRPr>
             </a:pPr>
             <a:r>
-              <a:t>Incident and notification workflows</a:t>
+              <a:t>Central agent lifecycle</a:t>
             </a:r>
           </a:p>
         </p:txBody>
@@ -13439,7 +13535,7 @@
               </a:defRPr>
             </a:pPr>
             <a:r>
-              <a:t>Investigations often involve several people and external operational systems. Incident records preserve ownership and decisions, while signed notifications carry relevant information to organisation-operated integrations, helping teams coordinate work and recover delivery after temporary service failures.</a:t>
+              <a:t>Host monitoring depends on knowing which agents are enrolled, authorised and reporting correctly. Central lifecycle controls help maintain that inventory, replace credentials, withdraw access and identify policy or version differences that require administrator attention.</a:t>
             </a:r>
           </a:p>
         </p:txBody>
@@ -13564,7 +13660,7 @@
               </a:defRPr>
             </a:pPr>
             <a:r>
-              <a:t>Investigation workflow</a:t>
+              <a:t>Credential management</a:t>
             </a:r>
           </a:p>
         </p:txBody>
@@ -13607,7 +13703,7 @@
               </a:defRPr>
             </a:pPr>
             <a:r>
-              <a:t>Link alerts to owned incident cases</a:t>
+              <a:t>Issue expiring, one-time enrollment credentials</a:t>
             </a:r>
           </a:p>
           <a:p>
@@ -13627,7 +13723,7 @@
               </a:defRPr>
             </a:pPr>
             <a:r>
-              <a:t>Track status, notes and evidence timelines</a:t>
+              <a:t>Store hashes of enrolled host credentials</a:t>
             </a:r>
           </a:p>
           <a:p>
@@ -13647,7 +13743,7 @@
               </a:defRPr>
             </a:pPr>
             <a:r>
-              <a:t>Protect concurrent edits with case versions</a:t>
+              <a:t>Rotate keys and revoke agent access centrally</a:t>
             </a:r>
           </a:p>
           <a:p>
@@ -13667,7 +13763,7 @@
               </a:defRPr>
             </a:pPr>
             <a:r>
-              <a:t>Review alerts and add scoped, expiring exceptions</a:t>
+              <a:t>Cancel unexecuted responses after revocation</a:t>
             </a:r>
           </a:p>
         </p:txBody>
@@ -13792,7 +13888,7 @@
               </a:defRPr>
             </a:pPr>
             <a:r>
-              <a:t>SIEM and ticketing bridges</a:t>
+              <a:t>Inventory and policy</a:t>
             </a:r>
           </a:p>
         </p:txBody>
@@ -13835,7 +13931,7 @@
               </a:defRPr>
             </a:pPr>
             <a:r>
-              <a:t>Send signed JSON to fixed HTTPS endpoints</a:t>
+              <a:t>Track platform, agent version and queue health</a:t>
             </a:r>
           </a:p>
           <a:p>
@@ -13855,7 +13951,7 @@
               </a:defRPr>
             </a:pPr>
             <a:r>
-              <a:t>Persist delivery state, leases and retry attempts</a:t>
+              <a:t>Record administrator policy-version history</a:t>
             </a:r>
           </a:p>
           <a:p>
@@ -13875,7 +13971,7 @@
               </a:defRPr>
             </a:pPr>
             <a:r>
-              <a:t>Attach stable keys for receiver deduplication</a:t>
+              <a:t>Flag drift from the desired software version</a:t>
             </a:r>
           </a:p>
           <a:p>
@@ -13895,7 +13991,7 @@
               </a:defRPr>
             </a:pPr>
             <a:r>
-              <a:t>Audit outcomes without storing upstream secrets</a:t>
+              <a:t>Keep privileged response enablement local to hosts</a:t>
             </a:r>
           </a:p>
         </p:txBody>
@@ -13934,7 +14030,7 @@
               </a:defRPr>
             </a:pPr>
             <a:r>
-              <a:t>Webhooks support organisation-operated adapters; native Jira, ServiceNow or Splunk connectors are not implied.</a:t>
+              <a:t>Agent software installation and upgrades use an administrator-controlled rollout.</a:t>
             </a:r>
           </a:p>
         </p:txBody>
@@ -14012,7 +14108,7 @@
               </a:defRPr>
             </a:pPr>
             <a:r>
-              <a:t>19 / 24</a:t>
+              <a:t>19 / 25</a:t>
             </a:r>
           </a:p>
         </p:txBody>
@@ -14766,7 +14862,7 @@
               </a:defRPr>
             </a:pPr>
             <a:r>
-              <a:t>02 / 24</a:t>
+              <a:t>02 / 25</a:t>
             </a:r>
           </a:p>
         </p:txBody>
@@ -14866,7 +14962,7 @@
               </a:defRPr>
             </a:pPr>
             <a:r>
-              <a:t>RECOVERY + MAINTENANCE</a:t>
+              <a:t>OWNERSHIP + EVIDENCE + DELIVERY</a:t>
             </a:r>
           </a:p>
         </p:txBody>
@@ -14905,7 +15001,7 @@
               </a:defRPr>
             </a:pPr>
             <a:r>
-              <a:t>Reliable delivery and retention</a:t>
+              <a:t>Incident and notification workflows</a:t>
             </a:r>
           </a:p>
         </p:txBody>
@@ -14947,7 +15043,7 @@
               </a:defRPr>
             </a:pPr>
             <a:r>
-              <a:t>Network interruptions and growing evidence volumes can affect security operations. Persistent queues and acknowledgement checks support recovery after outages, while backup and retention controls help teams manage stored evidence according to investigation needs and operational requirements.</a:t>
+              <a:t>Investigations often involve several people and external operational systems. Incident records preserve ownership and decisions, while signed notifications carry relevant information to organisation-operated integrations, helping teams coordinate work and recover delivery after temporary service failures.</a:t>
             </a:r>
           </a:p>
         </p:txBody>
@@ -15072,7 +15168,7 @@
               </a:defRPr>
             </a:pPr>
             <a:r>
-              <a:t>Telemetry continuity</a:t>
+              <a:t>Investigation workflow</a:t>
             </a:r>
           </a:p>
         </p:txBody>
@@ -15115,7 +15211,7 @@
               </a:defRPr>
             </a:pPr>
             <a:r>
-              <a:t>Keep events until exact acknowledgement</a:t>
+              <a:t>Link alerts to owned incident cases</a:t>
             </a:r>
           </a:p>
           <a:p>
@@ -15135,7 +15231,7 @@
               </a:defRPr>
             </a:pPr>
             <a:r>
-              <a:t>Replay retained events after service outages</a:t>
+              <a:t>Track status, notes and evidence timelines</a:t>
             </a:r>
           </a:p>
           <a:p>
@@ -15155,7 +15251,7 @@
               </a:defRPr>
             </a:pPr>
             <a:r>
-              <a:t>Pause collection visibly when the queue is full</a:t>
+              <a:t>Protect concurrent edits with case versions</a:t>
             </a:r>
           </a:p>
           <a:p>
@@ -15175,7 +15271,7 @@
               </a:defRPr>
             </a:pPr>
             <a:r>
-              <a:t>Archive older events without fresh containment</a:t>
+              <a:t>Review alerts and add scoped, expiring exceptions</a:t>
             </a:r>
           </a:p>
         </p:txBody>
@@ -15300,7 +15396,7 @@
               </a:defRPr>
             </a:pPr>
             <a:r>
-              <a:t>Evidence maintenance</a:t>
+              <a:t>SIEM and ticketing bridges</a:t>
             </a:r>
           </a:p>
         </p:txBody>
@@ -15343,7 +15439,7 @@
               </a:defRPr>
             </a:pPr>
             <a:r>
-              <a:t>Create consistent SQLite backups and verify restore</a:t>
+              <a:t>Send signed JSON to fixed HTTPS endpoints</a:t>
             </a:r>
           </a:p>
           <a:p>
@@ -15363,7 +15459,7 @@
               </a:defRPr>
             </a:pPr>
             <a:r>
-              <a:t>Preview retention cleanup before applying it</a:t>
+              <a:t>Persist delivery state, leases and retry attempts</a:t>
             </a:r>
           </a:p>
           <a:p>
@@ -15383,7 +15479,7 @@
               </a:defRPr>
             </a:pPr>
             <a:r>
-              <a:t>Preserve incident and response-linked evidence</a:t>
+              <a:t>Attach stable keys for receiver deduplication</a:t>
             </a:r>
           </a:p>
           <a:p>
@@ -15403,7 +15499,7 @@
               </a:defRPr>
             </a:pPr>
             <a:r>
-              <a:t>Create offline-agent and stale-sensor alerts</a:t>
+              <a:t>Audit outcomes without storing upstream secrets</a:t>
             </a:r>
           </a:p>
         </p:txBody>
@@ -15442,7 +15538,7 @@
               </a:defRPr>
             </a:pPr>
             <a:r>
-              <a:t>Schedule maintenance explicitly and measure capacity, recovery objectives and backup security in the target environment.</a:t>
+              <a:t>Webhooks support organisation-operated adapters; native Jira, ServiceNow or Splunk connectors are not implied.</a:t>
             </a:r>
           </a:p>
         </p:txBody>
@@ -15520,7 +15616,7 @@
               </a:defRPr>
             </a:pPr>
             <a:r>
-              <a:t>20 / 24</a:t>
+              <a:t>20 / 25</a:t>
             </a:r>
           </a:p>
         </p:txBody>
@@ -15620,7 +15716,7 @@
               </a:defRPr>
             </a:pPr>
             <a:r>
-              <a:t>IMAGE SUPPLY CHAIN + AIR-GAP</a:t>
+              <a:t>RECOVERY + MAINTENANCE</a:t>
             </a:r>
           </a:p>
         </p:txBody>
@@ -15659,7 +15755,7 @@
               </a:defRPr>
             </a:pPr>
             <a:r>
-              <a:t>Hardened deployment</a:t>
+              <a:t>Reliable delivery and retention</a:t>
             </a:r>
           </a:p>
         </p:txBody>
@@ -15701,7 +15797,7 @@
               </a:defRPr>
             </a:pPr>
             <a:r>
-              <a:t>A security tool that downloads twenty scanners is a supply-chain target. Every binary in the image is pinned to a known checksum and verified at build time, the containers run unprivileged, and the whole stack can operate without internet access using locally mirrored vulnerability data.</a:t>
+              <a:t>Network interruptions and growing evidence volumes can affect security operations. Persistent queues and acknowledgement checks support recovery after outages, while backup and retention controls help teams manage stored evidence according to investigation needs and operational requirements.</a:t>
             </a:r>
           </a:p>
         </p:txBody>
@@ -15826,7 +15922,7 @@
               </a:defRPr>
             </a:pPr>
             <a:r>
-              <a:t>Build integrity</a:t>
+              <a:t>Telemetry continuity</a:t>
             </a:r>
           </a:p>
         </p:txBody>
@@ -15869,7 +15965,7 @@
               </a:defRPr>
             </a:pPr>
             <a:r>
-              <a:t>Every scanner download SHA-256 pinned and verified</a:t>
+              <a:t>Keep events until exact acknowledgement</a:t>
             </a:r>
           </a:p>
           <a:p>
@@ -15889,7 +15985,7 @@
               </a:defRPr>
             </a:pPr>
             <a:r>
-              <a:t>No pipe-to-shell, no floating "latest" versions</a:t>
+              <a:t>Replay retained events after service outages</a:t>
             </a:r>
           </a:p>
           <a:p>
@@ -15909,7 +16005,7 @@
               </a:defRPr>
             </a:pPr>
             <a:r>
-              <a:t>Containers run as an unprivileged user</a:t>
+              <a:t>Pause collection visibly when the queue is full</a:t>
             </a:r>
           </a:p>
           <a:p>
@@ -15929,7 +16025,7 @@
               </a:defRPr>
             </a:pPr>
             <a:r>
-              <a:t>Hash-locked Python dependencies</a:t>
+              <a:t>Archive older events without fresh containment</a:t>
             </a:r>
           </a:p>
         </p:txBody>
@@ -16054,7 +16150,7 @@
               </a:defRPr>
             </a:pPr>
             <a:r>
-              <a:t>Runtime posture</a:t>
+              <a:t>Evidence maintenance</a:t>
             </a:r>
           </a:p>
         </p:txBody>
@@ -16097,7 +16193,7 @@
               </a:defRPr>
             </a:pPr>
             <a:r>
-              <a:t>Redis authenticated; browser origins explicit, never wildcard</a:t>
+              <a:t>Create consistent SQLite backups and verify restore</a:t>
             </a:r>
           </a:p>
           <a:p>
@@ -16117,7 +16213,7 @@
               </a:defRPr>
             </a:pPr>
             <a:r>
-              <a:t>No scanner telemetry egress</a:t>
+              <a:t>Preview retention cleanup before applying it</a:t>
             </a:r>
           </a:p>
           <a:p>
@@ -16137,7 +16233,7 @@
               </a:defRPr>
             </a:pPr>
             <a:r>
-              <a:t>Full offline mode with local vulnerability databases</a:t>
+              <a:t>Preserve incident and response-linked evidence</a:t>
             </a:r>
           </a:p>
           <a:p>
@@ -16157,7 +16253,7 @@
               </a:defRPr>
             </a:pPr>
             <a:r>
-              <a:t>Secrets injected from a vault, never baked into images</a:t>
+              <a:t>Create offline-agent and stale-sensor alerts</a:t>
             </a:r>
           </a:p>
         </p:txBody>
@@ -16196,7 +16292,7 @@
               </a:defRPr>
             </a:pPr>
             <a:r>
-              <a:t>Tests fail the build if any download lacks a pin or the runtime user is removed.</a:t>
+              <a:t>Schedule maintenance explicitly and measure capacity, recovery objectives and backup security in the target environment.</a:t>
             </a:r>
           </a:p>
         </p:txBody>
@@ -16274,7 +16370,7 @@
               </a:defRPr>
             </a:pPr>
             <a:r>
-              <a:t>21 / 24</a:t>
+              <a:t>21 / 25</a:t>
             </a:r>
           </a:p>
         </p:txBody>
@@ -16374,7 +16470,7 @@
               </a:defRPr>
             </a:pPr>
             <a:r>
-              <a:t>AUTOMATED CHECKS + NATIVE FILE CHECKS</a:t>
+              <a:t>IMAGE SUPPLY CHAIN + AIR-GAP</a:t>
             </a:r>
           </a:p>
         </p:txBody>
@@ -16413,7 +16509,7 @@
               </a:defRPr>
             </a:pPr>
             <a:r>
-              <a:t>Validation evidence</a:t>
+              <a:t>Hardened deployment</a:t>
             </a:r>
           </a:p>
         </p:txBody>
@@ -16455,7 +16551,7 @@
               </a:defRPr>
             </a:pPr>
             <a:r>
-              <a:t>The validation results demonstrate exercised code paths and selected native file behaviours. They provide evidence for technical review, while full containment effectiveness, host compatibility and operational performance require testing in the intended environment.</a:t>
+              <a:t>A security tool that downloads twenty scanners is a supply-chain target. Every binary in the image is pinned to a known checksum and verified at build time, the containers run unprivileged, and the whole stack can operate without internet access using locally mirrored vulnerability data.</a:t>
             </a:r>
           </a:p>
         </p:txBody>
@@ -16580,7 +16676,7 @@
               </a:defRPr>
             </a:pPr>
             <a:r>
-              <a:t>442 automated tests passed</a:t>
+              <a:t>Build integrity</a:t>
             </a:r>
           </a:p>
         </p:txBody>
@@ -16623,7 +16719,7 @@
               </a:defRPr>
             </a:pPr>
             <a:r>
-              <a:t>Access, roles, tenant and database-role boundaries</a:t>
+              <a:t>Every scanner download SHA-256 pinned and verified</a:t>
             </a:r>
           </a:p>
           <a:p>
@@ -16643,7 +16739,7 @@
               </a:defRPr>
             </a:pPr>
             <a:r>
-              <a:t>Target safety, scopes, cloud bindings and audit trail</a:t>
+              <a:t>No pipe-to-shell, no floating "latest" versions</a:t>
             </a:r>
           </a:p>
           <a:p>
@@ -16663,7 +16759,7 @@
               </a:defRPr>
             </a:pPr>
             <a:r>
-              <a:t>Triage, scan lifecycle and deployment pinning</a:t>
+              <a:t>Containers run as an unprivileged user</a:t>
             </a:r>
           </a:p>
           <a:p>
@@ -16683,7 +16779,7 @@
               </a:defRPr>
             </a:pPr>
             <a:r>
-              <a:t>Detection, enrollment, incident and response workflows</a:t>
+              <a:t>Hash-locked Python dependencies</a:t>
             </a:r>
           </a:p>
         </p:txBody>
@@ -16808,7 +16904,7 @@
               </a:defRPr>
             </a:pPr>
             <a:r>
-              <a:t>7 native Windows file checks passed</a:t>
+              <a:t>Runtime posture</a:t>
             </a:r>
           </a:p>
         </p:txBody>
@@ -16851,7 +16947,7 @@
               </a:defRPr>
             </a:pPr>
             <a:r>
-              <a:t>Disposable file-operation contract fixtures</a:t>
+              <a:t>Redis authenticated; browser origins explicit, never wildcard</a:t>
             </a:r>
           </a:p>
           <a:p>
@@ -16871,7 +16967,7 @@
               </a:defRPr>
             </a:pPr>
             <a:r>
-              <a:t>Pinned-handle relative rename behavior</a:t>
+              <a:t>No scanner telemetry egress</a:t>
             </a:r>
           </a:p>
           <a:p>
@@ -16891,7 +16987,7 @@
               </a:defRPr>
             </a:pPr>
             <a:r>
-              <a:t>File-sharing and junction-race checks</a:t>
+              <a:t>Full offline mode with local vulnerability databases</a:t>
             </a:r>
           </a:p>
           <a:p>
@@ -16911,7 +17007,7 @@
               </a:defRPr>
             </a:pPr>
             <a:r>
-              <a:t>Full ACL and firewall workflows require staging</a:t>
+              <a:t>Secrets injected from a vault, never baked into images</a:t>
             </a:r>
           </a:p>
         </p:txBody>
@@ -16950,7 +17046,7 @@
               </a:defRPr>
             </a:pPr>
             <a:r>
-              <a:t>Automated tests and narrow native file checks do not establish live containment efficacy or production readiness.</a:t>
+              <a:t>Tests fail the build if any download lacks a pin or the runtime user is removed.</a:t>
             </a:r>
           </a:p>
         </p:txBody>
@@ -17028,7 +17124,7 @@
               </a:defRPr>
             </a:pPr>
             <a:r>
-              <a:t>22 / 24</a:t>
+              <a:t>22 / 25</a:t>
             </a:r>
           </a:p>
         </p:txBody>
@@ -17128,7 +17224,7 @@
               </a:defRPr>
             </a:pPr>
             <a:r>
-              <a:t>DEPLOYMENT GATES</a:t>
+              <a:t>AUTOMATED CHECKS + NATIVE FILE CHECKS</a:t>
             </a:r>
           </a:p>
         </p:txBody>
@@ -17167,7 +17263,7 @@
               </a:defRPr>
             </a:pPr>
             <a:r>
-              <a:t>Required staging validation</a:t>
+              <a:t>Validation evidence</a:t>
             </a:r>
           </a:p>
         </p:txBody>
@@ -17209,7 +17305,7 @@
               </a:defRPr>
             </a:pPr>
             <a:r>
-              <a:t>Deployment conditions determine whether security controls work as intended. Staging should verify identity, database roles, telemetry, permissions, enforcement and recovery together, including how containment behaves during service interruptions and host restarts.</a:t>
+              <a:t>The validation results demonstrate exercised code paths and selected native file behaviours. They provide evidence for technical review, while full containment effectiveness, host compatibility and operational performance require testing in the intended environment.</a:t>
             </a:r>
           </a:p>
         </p:txBody>
@@ -17334,7 +17430,7 @@
               </a:defRPr>
             </a:pPr>
             <a:r>
-              <a:t>Identity and data</a:t>
+              <a:t>486 automated tests passed</a:t>
             </a:r>
           </a:p>
         </p:txBody>
@@ -17377,7 +17473,7 @@
               </a:defRPr>
             </a:pPr>
             <a:r>
-              <a:t>IdP issuance, token lifetime and revocation behavior</a:t>
+              <a:t>Access, roles, tenant and database-role boundaries</a:t>
             </a:r>
           </a:p>
           <a:p>
@@ -17397,7 +17493,7 @@
               </a:defRPr>
             </a:pPr>
             <a:r>
-              <a:t>PostgreSQL policies with both deployed database roles</a:t>
+              <a:t>Target safety, scopes, cloud bindings and audit trail</a:t>
             </a:r>
           </a:p>
           <a:p>
@@ -17417,7 +17513,7 @@
               </a:defRPr>
             </a:pPr>
             <a:r>
-              <a:t>Container image build and scanner compatibility</a:t>
+              <a:t>Triage, scan lifecycle and deployment pinning</a:t>
             </a:r>
           </a:p>
           <a:p>
@@ -17437,7 +17533,7 @@
               </a:defRPr>
             </a:pPr>
             <a:r>
-              <a:t>Existing-database migration rehearsal</a:t>
+              <a:t>Detection, enrollment, incident and response workflows</a:t>
             </a:r>
           </a:p>
         </p:txBody>
@@ -17562,7 +17658,7 @@
               </a:defRPr>
             </a:pPr>
             <a:r>
-              <a:t>Hosts and enforcement</a:t>
+              <a:t>7 native Windows file checks passed</a:t>
             </a:r>
           </a:p>
         </p:txBody>
@@ -17605,7 +17701,7 @@
               </a:defRPr>
             </a:pPr>
             <a:r>
-              <a:t>Windows Security/Sysmon and Linux audit collection</a:t>
+              <a:t>Disposable file-operation contract fixtures</a:t>
             </a:r>
           </a:p>
           <a:p>
@@ -17625,7 +17721,7 @@
               </a:defRPr>
             </a:pPr>
             <a:r>
-              <a:t>Cloudflare permissions, expiry and rule ordering</a:t>
+              <a:t>Pinned-handle relative rename behavior</a:t>
             </a:r>
           </a:p>
           <a:p>
@@ -17645,7 +17741,7 @@
               </a:defRPr>
             </a:pPr>
             <a:r>
-              <a:t>Linux/Windows isolation, expiry and rollback</a:t>
+              <a:t>File-sharing and junction-race checks</a:t>
             </a:r>
           </a:p>
           <a:p>
@@ -17665,7 +17761,7 @@
               </a:defRPr>
             </a:pPr>
             <a:r>
-              <a:t>False positives, overhead, backlog and recovery</a:t>
+              <a:t>Full ACL and firewall workflows require staging</a:t>
             </a:r>
           </a:p>
         </p:txBody>
@@ -17704,7 +17800,7 @@
               </a:defRPr>
             </a:pPr>
             <a:r>
-              <a:t>Validate native Windows ACLs, firewall enforcement, scheduled-task expiry and reboot recovery before enabling containment.</a:t>
+              <a:t>Automated tests and narrow native file checks do not establish live containment efficacy or production readiness.</a:t>
             </a:r>
           </a:p>
         </p:txBody>
@@ -17782,7 +17878,7 @@
               </a:defRPr>
             </a:pPr>
             <a:r>
-              <a:t>23 / 24</a:t>
+              <a:t>23 / 25</a:t>
             </a:r>
           </a:p>
         </p:txBody>
@@ -17882,7 +17978,7 @@
               </a:defRPr>
             </a:pPr>
             <a:r>
-              <a:t>DEPLOYMENT PLANNING</a:t>
+              <a:t>DEPLOYMENT GATES</a:t>
             </a:r>
           </a:p>
         </p:txBody>
@@ -17921,7 +18017,7 @@
               </a:defRPr>
             </a:pPr>
             <a:r>
-              <a:t>Evaluating fit for your organisation</a:t>
+              <a:t>Required staging validation</a:t>
             </a:r>
           </a:p>
         </p:txBody>
@@ -17963,7 +18059,7 @@
               </a:defRPr>
             </a:pPr>
             <a:r>
-              <a:t>A suitable deployment starts with clear asset scope, accountable owners and measurable acceptance criteria. These decisions help teams assess coverage, operational impact, recovery expectations and the conditions under which approved response should be enabled.</a:t>
+              <a:t>Deployment conditions determine whether security controls work as intended. Staging should verify identity, database roles, telemetry, permissions, enforcement and recovery together, including how containment behaves during service interruptions and host restarts.</a:t>
             </a:r>
           </a:p>
         </p:txBody>
@@ -18088,7 +18184,7 @@
               </a:defRPr>
             </a:pPr>
             <a:r>
-              <a:t>Scope and ownership</a:t>
+              <a:t>Identity and data</a:t>
             </a:r>
           </a:p>
         </p:txBody>
@@ -18131,7 +18227,7 @@
               </a:defRPr>
             </a:pPr>
             <a:r>
-              <a:t>Select applications, APIs, cloud accounts and servers</a:t>
+              <a:t>IdP issuance, token lifetime and revocation behavior</a:t>
             </a:r>
           </a:p>
           <a:p>
@@ -18151,7 +18247,7 @@
               </a:defRPr>
             </a:pPr>
             <a:r>
-              <a:t>Identify incident owners and response approvers</a:t>
+              <a:t>PostgreSQL policies with both deployed database roles</a:t>
             </a:r>
           </a:p>
           <a:p>
@@ -18171,7 +18267,7 @@
               </a:defRPr>
             </a:pPr>
             <a:r>
-              <a:t>Approve the domains and networks in scope</a:t>
+              <a:t>Container image build and scanner compatibility</a:t>
             </a:r>
           </a:p>
           <a:p>
@@ -18191,7 +18287,7 @@
               </a:defRPr>
             </a:pPr>
             <a:r>
-              <a:t>Agree retention and recovery requirements</a:t>
+              <a:t>Existing-database migration rehearsal</a:t>
             </a:r>
           </a:p>
         </p:txBody>
@@ -18316,7 +18412,7 @@
               </a:defRPr>
             </a:pPr>
             <a:r>
-              <a:t>Acceptance criteria</a:t>
+              <a:t>Hosts and enforcement</a:t>
             </a:r>
           </a:p>
         </p:txBody>
@@ -18359,7 +18455,7 @@
               </a:defRPr>
             </a:pPr>
             <a:r>
-              <a:t>Measure detection coverage and false positives</a:t>
+              <a:t>Windows Security/Sysmon and Linux audit collection</a:t>
             </a:r>
           </a:p>
           <a:p>
@@ -18379,7 +18475,7 @@
               </a:defRPr>
             </a:pPr>
             <a:r>
-              <a:t>Verify roles and separate-actor approval</a:t>
+              <a:t>Cloudflare permissions, expiry and rule ordering</a:t>
             </a:r>
           </a:p>
           <a:p>
@@ -18399,7 +18495,7 @@
               </a:defRPr>
             </a:pPr>
             <a:r>
-              <a:t>Exercise containment, expiry and restoration</a:t>
+              <a:t>Linux/Windows isolation, expiry and rollback</a:t>
             </a:r>
           </a:p>
           <a:p>
@@ -18419,7 +18515,7 @@
               </a:defRPr>
             </a:pPr>
             <a:r>
-              <a:t>Measure host overhead and service recovery</a:t>
+              <a:t>False positives, overhead, backlog and recovery</a:t>
             </a:r>
           </a:p>
         </p:txBody>
@@ -18458,7 +18554,7 @@
               </a:defRPr>
             </a:pPr>
             <a:r>
-              <a:t>Production deployment requires environment-specific validation and an approved operating procedure.</a:t>
+              <a:t>Validate native Windows ACLs, firewall enforcement, scheduled-task expiry and reboot recovery before enabling containment.</a:t>
             </a:r>
           </a:p>
         </p:txBody>
@@ -18536,7 +18632,761 @@
               </a:defRPr>
             </a:pPr>
             <a:r>
-              <a:t>24 / 24</a:t>
+              <a:t>24 / 25</a:t>
+            </a:r>
+          </a:p>
+        </p:txBody>
+      </p:sp>
+    </p:spTree>
+  </p:cSld>
+  <p:clrMapOvr>
+    <a:masterClrMapping/>
+  </p:clrMapOvr>
+</p:sld>
+</file>
+
+<file path=ppt/slides/slide25.xml><?xml version="1.0" encoding="utf-8"?>
+<p:sld xmlns:a="http://schemas.openxmlformats.org/drawingml/2006/main" xmlns:p="http://schemas.openxmlformats.org/presentationml/2006/main" xmlns:r="http://schemas.openxmlformats.org/officeDocument/2006/relationships">
+  <p:cSld>
+    <p:spTree>
+      <p:nvGrpSpPr>
+        <p:cNvPr id="1" name=""/>
+        <p:cNvGrpSpPr/>
+        <p:nvPr/>
+      </p:nvGrpSpPr>
+      <p:grpSpPr/>
+      <p:sp>
+        <p:nvSpPr>
+          <p:cNvPr id="2" name="Rectangle 1"/>
+          <p:cNvSpPr/>
+          <p:nvPr/>
+        </p:nvSpPr>
+        <p:spPr>
+          <a:xfrm>
+            <a:off x="0" y="0"/>
+            <a:ext cx="12191695" cy="91440"/>
+          </a:xfrm>
+          <a:prstGeom prst="rect">
+            <a:avLst/>
+          </a:prstGeom>
+          <a:solidFill>
+            <a:srgbClr val="F38020"/>
+          </a:solidFill>
+          <a:ln>
+            <a:noFill/>
+          </a:ln>
+        </p:spPr>
+        <p:style>
+          <a:lnRef idx="1">
+            <a:schemeClr val="accent1"/>
+          </a:lnRef>
+          <a:fillRef idx="3">
+            <a:schemeClr val="accent1"/>
+          </a:fillRef>
+          <a:effectRef idx="2">
+            <a:schemeClr val="accent1"/>
+          </a:effectRef>
+          <a:fontRef idx="minor">
+            <a:schemeClr val="lt1"/>
+          </a:fontRef>
+        </p:style>
+        <p:txBody>
+          <a:bodyPr rtlCol="0" anchor="ctr"/>
+          <a:lstStyle/>
+          <a:p>
+            <a:pPr algn="ctr"/>
+          </a:p>
+        </p:txBody>
+      </p:sp>
+      <p:sp>
+        <p:nvSpPr>
+          <p:cNvPr id="3" name="TextBox 2"/>
+          <p:cNvSpPr txBox="1"/>
+          <p:nvPr/>
+        </p:nvSpPr>
+        <p:spPr>
+          <a:xfrm>
+            <a:off x="502920" y="320040"/>
+            <a:ext cx="10972800" cy="274320"/>
+          </a:xfrm>
+          <a:prstGeom prst="rect">
+            <a:avLst/>
+          </a:prstGeom>
+          <a:noFill/>
+        </p:spPr>
+        <p:txBody>
+          <a:bodyPr wrap="square" lIns="0" rIns="0" tIns="0" bIns="0">
+            <a:noAutofit/>
+          </a:bodyPr>
+          <a:lstStyle/>
+          <a:p>
+            <a:pPr>
+              <a:spcAft>
+                <a:spcPts val="0"/>
+              </a:spcAft>
+              <a:defRPr sz="1100" b="1">
+                <a:solidFill>
+                  <a:srgbClr val="F38020"/>
+                </a:solidFill>
+                <a:latin typeface="DejaVu Sans"/>
+              </a:defRPr>
+            </a:pPr>
+            <a:r>
+              <a:t>DEPLOYMENT PLANNING</a:t>
+            </a:r>
+          </a:p>
+        </p:txBody>
+      </p:sp>
+      <p:sp>
+        <p:nvSpPr>
+          <p:cNvPr id="4" name="TextBox 3"/>
+          <p:cNvSpPr txBox="1"/>
+          <p:nvPr/>
+        </p:nvSpPr>
+        <p:spPr>
+          <a:xfrm>
+            <a:off x="502920" y="795528"/>
+            <a:ext cx="11155680" cy="594360"/>
+          </a:xfrm>
+          <a:prstGeom prst="rect">
+            <a:avLst/>
+          </a:prstGeom>
+          <a:noFill/>
+        </p:spPr>
+        <p:txBody>
+          <a:bodyPr wrap="square" lIns="0" rIns="0" tIns="0" bIns="0">
+            <a:noAutofit/>
+          </a:bodyPr>
+          <a:lstStyle/>
+          <a:p>
+            <a:pPr>
+              <a:spcAft>
+                <a:spcPts val="0"/>
+              </a:spcAft>
+              <a:defRPr sz="3400" b="1">
+                <a:solidFill>
+                  <a:srgbClr val="0A2540"/>
+                </a:solidFill>
+                <a:latin typeface="DejaVu Sans"/>
+              </a:defRPr>
+            </a:pPr>
+            <a:r>
+              <a:t>Evaluating fit for your organisation</a:t>
+            </a:r>
+          </a:p>
+        </p:txBody>
+      </p:sp>
+      <p:sp>
+        <p:nvSpPr>
+          <p:cNvPr id="5" name="TextBox 4"/>
+          <p:cNvSpPr txBox="1"/>
+          <p:nvPr/>
+        </p:nvSpPr>
+        <p:spPr>
+          <a:xfrm>
+            <a:off x="502920" y="1417320"/>
+            <a:ext cx="11155680" cy="768096"/>
+          </a:xfrm>
+          <a:prstGeom prst="rect">
+            <a:avLst/>
+          </a:prstGeom>
+          <a:noFill/>
+        </p:spPr>
+        <p:txBody>
+          <a:bodyPr wrap="square" lIns="0" rIns="0" tIns="0" bIns="0">
+            <a:noAutofit/>
+          </a:bodyPr>
+          <a:lstStyle/>
+          <a:p>
+            <a:pPr>
+              <a:lnSpc>
+                <a:spcPts val="2000"/>
+              </a:lnSpc>
+              <a:spcAft>
+                <a:spcPts val="0"/>
+              </a:spcAft>
+              <a:defRPr sz="1550" b="0">
+                <a:solidFill>
+                  <a:srgbClr val="334155"/>
+                </a:solidFill>
+                <a:latin typeface="DejaVu Sans"/>
+              </a:defRPr>
+            </a:pPr>
+            <a:r>
+              <a:t>A suitable deployment starts with clear asset scope, accountable owners and measurable acceptance criteria. These decisions help teams assess coverage, operational impact, recovery expectations and the conditions under which approved response should be enabled.</a:t>
+            </a:r>
+          </a:p>
+        </p:txBody>
+      </p:sp>
+      <p:sp>
+        <p:nvSpPr>
+          <p:cNvPr id="6" name="Rectangle 5"/>
+          <p:cNvSpPr/>
+          <p:nvPr/>
+        </p:nvSpPr>
+        <p:spPr>
+          <a:xfrm>
+            <a:off x="502920" y="2331720"/>
+            <a:ext cx="5404104" cy="3657600"/>
+          </a:xfrm>
+          <a:prstGeom prst="rect">
+            <a:avLst/>
+          </a:prstGeom>
+          <a:solidFill>
+            <a:srgbClr val="F3F6FA"/>
+          </a:solidFill>
+          <a:ln>
+            <a:noFill/>
+          </a:ln>
+        </p:spPr>
+        <p:style>
+          <a:lnRef idx="1">
+            <a:schemeClr val="accent1"/>
+          </a:lnRef>
+          <a:fillRef idx="3">
+            <a:schemeClr val="accent1"/>
+          </a:fillRef>
+          <a:effectRef idx="2">
+            <a:schemeClr val="accent1"/>
+          </a:effectRef>
+          <a:fontRef idx="minor">
+            <a:schemeClr val="lt1"/>
+          </a:fontRef>
+        </p:style>
+        <p:txBody>
+          <a:bodyPr rtlCol="0" anchor="ctr"/>
+          <a:lstStyle/>
+          <a:p>
+            <a:pPr algn="ctr"/>
+          </a:p>
+        </p:txBody>
+      </p:sp>
+      <p:sp>
+        <p:nvSpPr>
+          <p:cNvPr id="7" name="Rectangle 6"/>
+          <p:cNvSpPr/>
+          <p:nvPr/>
+        </p:nvSpPr>
+        <p:spPr>
+          <a:xfrm>
+            <a:off x="502920" y="2331720"/>
+            <a:ext cx="45720" cy="3657600"/>
+          </a:xfrm>
+          <a:prstGeom prst="rect">
+            <a:avLst/>
+          </a:prstGeom>
+          <a:solidFill>
+            <a:srgbClr val="F38020"/>
+          </a:solidFill>
+          <a:ln>
+            <a:noFill/>
+          </a:ln>
+        </p:spPr>
+        <p:style>
+          <a:lnRef idx="1">
+            <a:schemeClr val="accent1"/>
+          </a:lnRef>
+          <a:fillRef idx="3">
+            <a:schemeClr val="accent1"/>
+          </a:fillRef>
+          <a:effectRef idx="2">
+            <a:schemeClr val="accent1"/>
+          </a:effectRef>
+          <a:fontRef idx="minor">
+            <a:schemeClr val="lt1"/>
+          </a:fontRef>
+        </p:style>
+        <p:txBody>
+          <a:bodyPr rtlCol="0" anchor="ctr"/>
+          <a:lstStyle/>
+          <a:p>
+            <a:pPr algn="ctr"/>
+          </a:p>
+        </p:txBody>
+      </p:sp>
+      <p:sp>
+        <p:nvSpPr>
+          <p:cNvPr id="8" name="TextBox 7"/>
+          <p:cNvSpPr txBox="1"/>
+          <p:nvPr/>
+        </p:nvSpPr>
+        <p:spPr>
+          <a:xfrm>
+            <a:off x="749808" y="2542032"/>
+            <a:ext cx="4901184" cy="594360"/>
+          </a:xfrm>
+          <a:prstGeom prst="rect">
+            <a:avLst/>
+          </a:prstGeom>
+          <a:noFill/>
+        </p:spPr>
+        <p:txBody>
+          <a:bodyPr wrap="square" lIns="0" rIns="0" tIns="0" bIns="0">
+            <a:noAutofit/>
+          </a:bodyPr>
+          <a:lstStyle/>
+          <a:p>
+            <a:pPr>
+              <a:spcAft>
+                <a:spcPts val="0"/>
+              </a:spcAft>
+              <a:defRPr sz="2000" b="1">
+                <a:solidFill>
+                  <a:srgbClr val="0A2540"/>
+                </a:solidFill>
+                <a:latin typeface="DejaVu Sans"/>
+              </a:defRPr>
+            </a:pPr>
+            <a:r>
+              <a:t>Scope and ownership</a:t>
+            </a:r>
+          </a:p>
+        </p:txBody>
+      </p:sp>
+      <p:sp>
+        <p:nvSpPr>
+          <p:cNvPr id="9" name="TextBox 8"/>
+          <p:cNvSpPr txBox="1"/>
+          <p:nvPr/>
+        </p:nvSpPr>
+        <p:spPr>
+          <a:xfrm>
+            <a:off x="749808" y="3236976"/>
+            <a:ext cx="4846320" cy="2615184"/>
+          </a:xfrm>
+          <a:prstGeom prst="rect">
+            <a:avLst/>
+          </a:prstGeom>
+          <a:noFill/>
+        </p:spPr>
+        <p:txBody>
+          <a:bodyPr wrap="square" lIns="0" rIns="0" tIns="0" bIns="0">
+            <a:noAutofit/>
+          </a:bodyPr>
+          <a:lstStyle/>
+          <a:p>
+            <a:pPr marL="182880" indent="-164592">
+              <a:lnSpc>
+                <a:spcPts val="2200"/>
+              </a:lnSpc>
+              <a:spcAft>
+                <a:spcPts val="800"/>
+              </a:spcAft>
+              <a:buChar char="•"/>
+              <a:defRPr sz="1700" b="0">
+                <a:solidFill>
+                  <a:srgbClr val="334155"/>
+                </a:solidFill>
+                <a:latin typeface="DejaVu Sans"/>
+              </a:defRPr>
+            </a:pPr>
+            <a:r>
+              <a:t>Select applications, APIs, cloud accounts and servers</a:t>
+            </a:r>
+          </a:p>
+          <a:p>
+            <a:pPr marL="182880" indent="-164592">
+              <a:lnSpc>
+                <a:spcPts val="2200"/>
+              </a:lnSpc>
+              <a:spcAft>
+                <a:spcPts val="800"/>
+              </a:spcAft>
+              <a:buChar char="•"/>
+              <a:defRPr sz="1700">
+                <a:solidFill>
+                  <a:srgbClr val="334155"/>
+                </a:solidFill>
+                <a:latin typeface="DejaVu Sans"/>
+              </a:defRPr>
+            </a:pPr>
+            <a:r>
+              <a:t>Identify incident owners and response approvers</a:t>
+            </a:r>
+          </a:p>
+          <a:p>
+            <a:pPr marL="182880" indent="-164592">
+              <a:lnSpc>
+                <a:spcPts val="2200"/>
+              </a:lnSpc>
+              <a:spcAft>
+                <a:spcPts val="800"/>
+              </a:spcAft>
+              <a:buChar char="•"/>
+              <a:defRPr sz="1700">
+                <a:solidFill>
+                  <a:srgbClr val="334155"/>
+                </a:solidFill>
+                <a:latin typeface="DejaVu Sans"/>
+              </a:defRPr>
+            </a:pPr>
+            <a:r>
+              <a:t>Approve the domains and networks in scope</a:t>
+            </a:r>
+          </a:p>
+          <a:p>
+            <a:pPr marL="182880" indent="-164592">
+              <a:lnSpc>
+                <a:spcPts val="2200"/>
+              </a:lnSpc>
+              <a:spcAft>
+                <a:spcPts val="800"/>
+              </a:spcAft>
+              <a:buChar char="•"/>
+              <a:defRPr sz="1700">
+                <a:solidFill>
+                  <a:srgbClr val="334155"/>
+                </a:solidFill>
+                <a:latin typeface="DejaVu Sans"/>
+              </a:defRPr>
+            </a:pPr>
+            <a:r>
+              <a:t>Agree retention and recovery requirements</a:t>
+            </a:r>
+          </a:p>
+        </p:txBody>
+      </p:sp>
+      <p:sp>
+        <p:nvSpPr>
+          <p:cNvPr id="10" name="Rectangle 9"/>
+          <p:cNvSpPr/>
+          <p:nvPr/>
+        </p:nvSpPr>
+        <p:spPr>
+          <a:xfrm>
+            <a:off x="6281928" y="2331720"/>
+            <a:ext cx="5404104" cy="3657600"/>
+          </a:xfrm>
+          <a:prstGeom prst="rect">
+            <a:avLst/>
+          </a:prstGeom>
+          <a:solidFill>
+            <a:srgbClr val="F3F6FA"/>
+          </a:solidFill>
+          <a:ln>
+            <a:noFill/>
+          </a:ln>
+        </p:spPr>
+        <p:style>
+          <a:lnRef idx="1">
+            <a:schemeClr val="accent1"/>
+          </a:lnRef>
+          <a:fillRef idx="3">
+            <a:schemeClr val="accent1"/>
+          </a:fillRef>
+          <a:effectRef idx="2">
+            <a:schemeClr val="accent1"/>
+          </a:effectRef>
+          <a:fontRef idx="minor">
+            <a:schemeClr val="lt1"/>
+          </a:fontRef>
+        </p:style>
+        <p:txBody>
+          <a:bodyPr rtlCol="0" anchor="ctr"/>
+          <a:lstStyle/>
+          <a:p>
+            <a:pPr algn="ctr"/>
+          </a:p>
+        </p:txBody>
+      </p:sp>
+      <p:sp>
+        <p:nvSpPr>
+          <p:cNvPr id="11" name="Rectangle 10"/>
+          <p:cNvSpPr/>
+          <p:nvPr/>
+        </p:nvSpPr>
+        <p:spPr>
+          <a:xfrm>
+            <a:off x="6281928" y="2331720"/>
+            <a:ext cx="45720" cy="3657600"/>
+          </a:xfrm>
+          <a:prstGeom prst="rect">
+            <a:avLst/>
+          </a:prstGeom>
+          <a:solidFill>
+            <a:srgbClr val="F38020"/>
+          </a:solidFill>
+          <a:ln>
+            <a:noFill/>
+          </a:ln>
+        </p:spPr>
+        <p:style>
+          <a:lnRef idx="1">
+            <a:schemeClr val="accent1"/>
+          </a:lnRef>
+          <a:fillRef idx="3">
+            <a:schemeClr val="accent1"/>
+          </a:fillRef>
+          <a:effectRef idx="2">
+            <a:schemeClr val="accent1"/>
+          </a:effectRef>
+          <a:fontRef idx="minor">
+            <a:schemeClr val="lt1"/>
+          </a:fontRef>
+        </p:style>
+        <p:txBody>
+          <a:bodyPr rtlCol="0" anchor="ctr"/>
+          <a:lstStyle/>
+          <a:p>
+            <a:pPr algn="ctr"/>
+          </a:p>
+        </p:txBody>
+      </p:sp>
+      <p:sp>
+        <p:nvSpPr>
+          <p:cNvPr id="12" name="TextBox 11"/>
+          <p:cNvSpPr txBox="1"/>
+          <p:nvPr/>
+        </p:nvSpPr>
+        <p:spPr>
+          <a:xfrm>
+            <a:off x="6528816" y="2542032"/>
+            <a:ext cx="4901184" cy="594360"/>
+          </a:xfrm>
+          <a:prstGeom prst="rect">
+            <a:avLst/>
+          </a:prstGeom>
+          <a:noFill/>
+        </p:spPr>
+        <p:txBody>
+          <a:bodyPr wrap="square" lIns="0" rIns="0" tIns="0" bIns="0">
+            <a:noAutofit/>
+          </a:bodyPr>
+          <a:lstStyle/>
+          <a:p>
+            <a:pPr>
+              <a:spcAft>
+                <a:spcPts val="0"/>
+              </a:spcAft>
+              <a:defRPr sz="2000" b="1">
+                <a:solidFill>
+                  <a:srgbClr val="0A2540"/>
+                </a:solidFill>
+                <a:latin typeface="DejaVu Sans"/>
+              </a:defRPr>
+            </a:pPr>
+            <a:r>
+              <a:t>Acceptance criteria</a:t>
+            </a:r>
+          </a:p>
+        </p:txBody>
+      </p:sp>
+      <p:sp>
+        <p:nvSpPr>
+          <p:cNvPr id="13" name="TextBox 12"/>
+          <p:cNvSpPr txBox="1"/>
+          <p:nvPr/>
+        </p:nvSpPr>
+        <p:spPr>
+          <a:xfrm>
+            <a:off x="6528816" y="3236976"/>
+            <a:ext cx="4846320" cy="2615184"/>
+          </a:xfrm>
+          <a:prstGeom prst="rect">
+            <a:avLst/>
+          </a:prstGeom>
+          <a:noFill/>
+        </p:spPr>
+        <p:txBody>
+          <a:bodyPr wrap="square" lIns="0" rIns="0" tIns="0" bIns="0">
+            <a:noAutofit/>
+          </a:bodyPr>
+          <a:lstStyle/>
+          <a:p>
+            <a:pPr marL="182880" indent="-164592">
+              <a:lnSpc>
+                <a:spcPts val="2200"/>
+              </a:lnSpc>
+              <a:spcAft>
+                <a:spcPts val="800"/>
+              </a:spcAft>
+              <a:buChar char="•"/>
+              <a:defRPr sz="1700" b="0">
+                <a:solidFill>
+                  <a:srgbClr val="334155"/>
+                </a:solidFill>
+                <a:latin typeface="DejaVu Sans"/>
+              </a:defRPr>
+            </a:pPr>
+            <a:r>
+              <a:t>Measure detection coverage and false positives</a:t>
+            </a:r>
+          </a:p>
+          <a:p>
+            <a:pPr marL="182880" indent="-164592">
+              <a:lnSpc>
+                <a:spcPts val="2200"/>
+              </a:lnSpc>
+              <a:spcAft>
+                <a:spcPts val="800"/>
+              </a:spcAft>
+              <a:buChar char="•"/>
+              <a:defRPr sz="1700">
+                <a:solidFill>
+                  <a:srgbClr val="334155"/>
+                </a:solidFill>
+                <a:latin typeface="DejaVu Sans"/>
+              </a:defRPr>
+            </a:pPr>
+            <a:r>
+              <a:t>Verify roles and separate-actor approval</a:t>
+            </a:r>
+          </a:p>
+          <a:p>
+            <a:pPr marL="182880" indent="-164592">
+              <a:lnSpc>
+                <a:spcPts val="2200"/>
+              </a:lnSpc>
+              <a:spcAft>
+                <a:spcPts val="800"/>
+              </a:spcAft>
+              <a:buChar char="•"/>
+              <a:defRPr sz="1700">
+                <a:solidFill>
+                  <a:srgbClr val="334155"/>
+                </a:solidFill>
+                <a:latin typeface="DejaVu Sans"/>
+              </a:defRPr>
+            </a:pPr>
+            <a:r>
+              <a:t>Exercise containment, expiry and restoration</a:t>
+            </a:r>
+          </a:p>
+          <a:p>
+            <a:pPr marL="182880" indent="-164592">
+              <a:lnSpc>
+                <a:spcPts val="2200"/>
+              </a:lnSpc>
+              <a:spcAft>
+                <a:spcPts val="800"/>
+              </a:spcAft>
+              <a:buChar char="•"/>
+              <a:defRPr sz="1700">
+                <a:solidFill>
+                  <a:srgbClr val="334155"/>
+                </a:solidFill>
+                <a:latin typeface="DejaVu Sans"/>
+              </a:defRPr>
+            </a:pPr>
+            <a:r>
+              <a:t>Measure host overhead and service recovery</a:t>
+            </a:r>
+          </a:p>
+        </p:txBody>
+      </p:sp>
+      <p:sp>
+        <p:nvSpPr>
+          <p:cNvPr id="14" name="TextBox 13"/>
+          <p:cNvSpPr txBox="1"/>
+          <p:nvPr/>
+        </p:nvSpPr>
+        <p:spPr>
+          <a:xfrm>
+            <a:off x="502920" y="6080760"/>
+            <a:ext cx="11155680" cy="384048"/>
+          </a:xfrm>
+          <a:prstGeom prst="rect">
+            <a:avLst/>
+          </a:prstGeom>
+          <a:noFill/>
+        </p:spPr>
+        <p:txBody>
+          <a:bodyPr wrap="square" lIns="0" rIns="0" tIns="0" bIns="0">
+            <a:noAutofit/>
+          </a:bodyPr>
+          <a:lstStyle/>
+          <a:p>
+            <a:pPr>
+              <a:spcAft>
+                <a:spcPts val="0"/>
+              </a:spcAft>
+              <a:defRPr sz="1100" b="0">
+                <a:solidFill>
+                  <a:srgbClr val="64748B"/>
+                </a:solidFill>
+                <a:latin typeface="DejaVu Sans"/>
+              </a:defRPr>
+            </a:pPr>
+            <a:r>
+              <a:t>Production deployment requires environment-specific validation and an approved operating procedure.</a:t>
+            </a:r>
+          </a:p>
+        </p:txBody>
+      </p:sp>
+      <p:sp>
+        <p:nvSpPr>
+          <p:cNvPr id="15" name="TextBox 14"/>
+          <p:cNvSpPr txBox="1"/>
+          <p:nvPr/>
+        </p:nvSpPr>
+        <p:spPr>
+          <a:xfrm>
+            <a:off x="502920" y="6519672"/>
+            <a:ext cx="10058400" cy="182880"/>
+          </a:xfrm>
+          <a:prstGeom prst="rect">
+            <a:avLst/>
+          </a:prstGeom>
+          <a:noFill/>
+        </p:spPr>
+        <p:txBody>
+          <a:bodyPr wrap="square" lIns="0" rIns="0" tIns="0" bIns="0">
+            <a:noAutofit/>
+          </a:bodyPr>
+          <a:lstStyle/>
+          <a:p>
+            <a:pPr>
+              <a:spcAft>
+                <a:spcPts val="0"/>
+              </a:spcAft>
+              <a:defRPr sz="900" b="0">
+                <a:solidFill>
+                  <a:srgbClr val="64748B"/>
+                </a:solidFill>
+                <a:latin typeface="DejaVu Sans"/>
+              </a:defRPr>
+            </a:pPr>
+            <a:r>
+              <a:t>CONFIDENTIAL • INTERNAL REVIEW  |  19 October 2026</a:t>
+            </a:r>
+          </a:p>
+        </p:txBody>
+      </p:sp>
+      <p:sp>
+        <p:nvSpPr>
+          <p:cNvPr id="16" name="TextBox 15"/>
+          <p:cNvSpPr txBox="1"/>
+          <p:nvPr/>
+        </p:nvSpPr>
+        <p:spPr>
+          <a:xfrm>
+            <a:off x="11045952" y="6519672"/>
+            <a:ext cx="685800" cy="182880"/>
+          </a:xfrm>
+          <a:prstGeom prst="rect">
+            <a:avLst/>
+          </a:prstGeom>
+          <a:noFill/>
+        </p:spPr>
+        <p:txBody>
+          <a:bodyPr wrap="square" lIns="0" rIns="0" tIns="0" bIns="0">
+            <a:noAutofit/>
+          </a:bodyPr>
+          <a:lstStyle/>
+          <a:p>
+            <a:pPr>
+              <a:spcAft>
+                <a:spcPts val="0"/>
+              </a:spcAft>
+              <a:defRPr sz="900" b="0">
+                <a:solidFill>
+                  <a:srgbClr val="64748B"/>
+                </a:solidFill>
+                <a:latin typeface="DejaVu Sans"/>
+              </a:defRPr>
+            </a:pPr>
+            <a:r>
+              <a:t>25 / 25</a:t>
             </a:r>
           </a:p>
         </p:txBody>
@@ -19290,7 +20140,7 @@
               </a:defRPr>
             </a:pPr>
             <a:r>
-              <a:t>03 / 24</a:t>
+              <a:t>03 / 25</a:t>
             </a:r>
           </a:p>
         </p:txBody>
@@ -20044,7 +20894,7 @@
               </a:defRPr>
             </a:pPr>
             <a:r>
-              <a:t>04 / 24</a:t>
+              <a:t>04 / 25</a:t>
             </a:r>
           </a:p>
         </p:txBody>
@@ -20798,7 +21648,7 @@
               </a:defRPr>
             </a:pPr>
             <a:r>
-              <a:t>05 / 24</a:t>
+              <a:t>05 / 25</a:t>
             </a:r>
           </a:p>
         </p:txBody>
@@ -21552,7 +22402,7 @@
               </a:defRPr>
             </a:pPr>
             <a:r>
-              <a:t>06 / 24</a:t>
+              <a:t>06 / 25</a:t>
             </a:r>
           </a:p>
         </p:txBody>
@@ -22306,7 +23156,7 @@
               </a:defRPr>
             </a:pPr>
             <a:r>
-              <a:t>07 / 24</a:t>
+              <a:t>07 / 25</a:t>
             </a:r>
           </a:p>
         </p:txBody>
@@ -23060,7 +23910,7 @@
               </a:defRPr>
             </a:pPr>
             <a:r>
-              <a:t>08 / 24</a:t>
+              <a:t>08 / 25</a:t>
             </a:r>
           </a:p>
         </p:txBody>
@@ -23814,7 +24664,7 @@
               </a:defRPr>
             </a:pPr>
             <a:r>
-              <a:t>09 / 24</a:t>
+              <a:t>09 / 25</a:t>
             </a:r>
           </a:p>
         </p:txBody>

</xml_diff>